<commit_message>
backtest.py: dollar P&L on $100k by year, equity curve chart and CSV; deck slide 5 shows the curve
Co-Authored-By: Claude Fable 5.1 <noreply@anthropic.com>
</commit_message>
<xml_diff>
--- a/slides/SCF_DayTrading_Bot_6.pptx
+++ b/slides/SCF_DayTrading_Bot_6.pptx
@@ -8222,9 +8222,9 @@
   <c:chart>
     <c:autoTitleDeleted val="0"/>
     <c:plotArea>
-      <c:barChart>
-        <c:barDir val="col"/>
-        <c:grouping val="clustered"/>
+      <c:lineChart>
+        <c:grouping val="standard"/>
+        <c:varyColors val="0"/>
         <c:ser>
           <c:idx val="0"/>
           <c:order val="0"/>
@@ -8234,64 +8234,814 @@
               <c:strCache>
                 <c:ptCount val="1"/>
                 <c:pt idx="0">
-                  <c:v>QQQ</c:v>
+                  <c:v>QQQ  (+131,207)</c:v>
                 </c:pt>
               </c:strCache>
             </c:strRef>
           </c:tx>
           <c:spPr>
-            <a:solidFill>
-              <a:srgbClr val="F2A900"/>
-            </a:solidFill>
+            <a:ln w="22225">
+              <a:solidFill>
+                <a:srgbClr val="F2A900"/>
+              </a:solidFill>
+            </a:ln>
           </c:spPr>
-          <c:invertIfNegative val="0"/>
+          <c:marker>
+            <c:symbol val="none"/>
+          </c:marker>
           <c:cat>
-            <c:strRef>
-              <c:f>Sheet1!$A$2:$A$6</c:f>
-              <c:strCache>
-                <c:ptCount val="5"/>
+            <c:numRef>
+              <c:f>Sheet1!$A$2:$A$130</c:f>
+              <c:numCache>
+                <c:formatCode>yyyy\-mm\-dd</c:formatCode>
+                <c:ptCount val="129"/>
                 <c:pt idx="0">
-                  <c:v>5 min</c:v>
+                  <c:v>42400.0</c:v>
                 </c:pt>
                 <c:pt idx="1">
-                  <c:v>15 min</c:v>
+                  <c:v>42429.0</c:v>
                 </c:pt>
                 <c:pt idx="2">
-                  <c:v>30 min</c:v>
+                  <c:v>42460.0</c:v>
                 </c:pt>
                 <c:pt idx="3">
-                  <c:v>60 min</c:v>
+                  <c:v>42490.0</c:v>
                 </c:pt>
                 <c:pt idx="4">
-                  <c:v>30 + 5-min stop</c:v>
-                </c:pt>
-              </c:strCache>
-            </c:strRef>
+                  <c:v>42521.0</c:v>
+                </c:pt>
+                <c:pt idx="5">
+                  <c:v>42551.0</c:v>
+                </c:pt>
+                <c:pt idx="6">
+                  <c:v>42582.0</c:v>
+                </c:pt>
+                <c:pt idx="7">
+                  <c:v>42613.0</c:v>
+                </c:pt>
+                <c:pt idx="8">
+                  <c:v>42643.0</c:v>
+                </c:pt>
+                <c:pt idx="9">
+                  <c:v>42674.0</c:v>
+                </c:pt>
+                <c:pt idx="10">
+                  <c:v>42704.0</c:v>
+                </c:pt>
+                <c:pt idx="11">
+                  <c:v>42735.0</c:v>
+                </c:pt>
+                <c:pt idx="12">
+                  <c:v>42766.0</c:v>
+                </c:pt>
+                <c:pt idx="13">
+                  <c:v>42794.0</c:v>
+                </c:pt>
+                <c:pt idx="14">
+                  <c:v>42825.0</c:v>
+                </c:pt>
+                <c:pt idx="15">
+                  <c:v>42855.0</c:v>
+                </c:pt>
+                <c:pt idx="16">
+                  <c:v>42886.0</c:v>
+                </c:pt>
+                <c:pt idx="17">
+                  <c:v>42916.0</c:v>
+                </c:pt>
+                <c:pt idx="18">
+                  <c:v>42947.0</c:v>
+                </c:pt>
+                <c:pt idx="19">
+                  <c:v>42978.0</c:v>
+                </c:pt>
+                <c:pt idx="20">
+                  <c:v>43008.0</c:v>
+                </c:pt>
+                <c:pt idx="21">
+                  <c:v>43039.0</c:v>
+                </c:pt>
+                <c:pt idx="22">
+                  <c:v>43069.0</c:v>
+                </c:pt>
+                <c:pt idx="23">
+                  <c:v>43100.0</c:v>
+                </c:pt>
+                <c:pt idx="24">
+                  <c:v>43131.0</c:v>
+                </c:pt>
+                <c:pt idx="25">
+                  <c:v>43159.0</c:v>
+                </c:pt>
+                <c:pt idx="26">
+                  <c:v>43190.0</c:v>
+                </c:pt>
+                <c:pt idx="27">
+                  <c:v>43220.0</c:v>
+                </c:pt>
+                <c:pt idx="28">
+                  <c:v>43251.0</c:v>
+                </c:pt>
+                <c:pt idx="29">
+                  <c:v>43281.0</c:v>
+                </c:pt>
+                <c:pt idx="30">
+                  <c:v>43312.0</c:v>
+                </c:pt>
+                <c:pt idx="31">
+                  <c:v>43343.0</c:v>
+                </c:pt>
+                <c:pt idx="32">
+                  <c:v>43373.0</c:v>
+                </c:pt>
+                <c:pt idx="33">
+                  <c:v>43404.0</c:v>
+                </c:pt>
+                <c:pt idx="34">
+                  <c:v>43434.0</c:v>
+                </c:pt>
+                <c:pt idx="35">
+                  <c:v>43465.0</c:v>
+                </c:pt>
+                <c:pt idx="36">
+                  <c:v>43496.0</c:v>
+                </c:pt>
+                <c:pt idx="37">
+                  <c:v>43524.0</c:v>
+                </c:pt>
+                <c:pt idx="38">
+                  <c:v>43555.0</c:v>
+                </c:pt>
+                <c:pt idx="39">
+                  <c:v>43585.0</c:v>
+                </c:pt>
+                <c:pt idx="40">
+                  <c:v>43616.0</c:v>
+                </c:pt>
+                <c:pt idx="41">
+                  <c:v>43646.0</c:v>
+                </c:pt>
+                <c:pt idx="42">
+                  <c:v>43677.0</c:v>
+                </c:pt>
+                <c:pt idx="43">
+                  <c:v>43708.0</c:v>
+                </c:pt>
+                <c:pt idx="44">
+                  <c:v>43738.0</c:v>
+                </c:pt>
+                <c:pt idx="45">
+                  <c:v>43769.0</c:v>
+                </c:pt>
+                <c:pt idx="46">
+                  <c:v>43799.0</c:v>
+                </c:pt>
+                <c:pt idx="47">
+                  <c:v>43830.0</c:v>
+                </c:pt>
+                <c:pt idx="48">
+                  <c:v>43861.0</c:v>
+                </c:pt>
+                <c:pt idx="49">
+                  <c:v>43890.0</c:v>
+                </c:pt>
+                <c:pt idx="50">
+                  <c:v>43921.0</c:v>
+                </c:pt>
+                <c:pt idx="51">
+                  <c:v>43951.0</c:v>
+                </c:pt>
+                <c:pt idx="52">
+                  <c:v>43982.0</c:v>
+                </c:pt>
+                <c:pt idx="53">
+                  <c:v>44012.0</c:v>
+                </c:pt>
+                <c:pt idx="54">
+                  <c:v>44043.0</c:v>
+                </c:pt>
+                <c:pt idx="55">
+                  <c:v>44074.0</c:v>
+                </c:pt>
+                <c:pt idx="56">
+                  <c:v>44104.0</c:v>
+                </c:pt>
+                <c:pt idx="57">
+                  <c:v>44135.0</c:v>
+                </c:pt>
+                <c:pt idx="58">
+                  <c:v>44165.0</c:v>
+                </c:pt>
+                <c:pt idx="59">
+                  <c:v>44196.0</c:v>
+                </c:pt>
+                <c:pt idx="60">
+                  <c:v>44227.0</c:v>
+                </c:pt>
+                <c:pt idx="61">
+                  <c:v>44255.0</c:v>
+                </c:pt>
+                <c:pt idx="62">
+                  <c:v>44286.0</c:v>
+                </c:pt>
+                <c:pt idx="63">
+                  <c:v>44316.0</c:v>
+                </c:pt>
+                <c:pt idx="64">
+                  <c:v>44347.0</c:v>
+                </c:pt>
+                <c:pt idx="65">
+                  <c:v>44377.0</c:v>
+                </c:pt>
+                <c:pt idx="66">
+                  <c:v>44408.0</c:v>
+                </c:pt>
+                <c:pt idx="67">
+                  <c:v>44439.0</c:v>
+                </c:pt>
+                <c:pt idx="68">
+                  <c:v>44469.0</c:v>
+                </c:pt>
+                <c:pt idx="69">
+                  <c:v>44500.0</c:v>
+                </c:pt>
+                <c:pt idx="70">
+                  <c:v>44530.0</c:v>
+                </c:pt>
+                <c:pt idx="71">
+                  <c:v>44561.0</c:v>
+                </c:pt>
+                <c:pt idx="72">
+                  <c:v>44592.0</c:v>
+                </c:pt>
+                <c:pt idx="73">
+                  <c:v>44620.0</c:v>
+                </c:pt>
+                <c:pt idx="74">
+                  <c:v>44651.0</c:v>
+                </c:pt>
+                <c:pt idx="75">
+                  <c:v>44681.0</c:v>
+                </c:pt>
+                <c:pt idx="76">
+                  <c:v>44712.0</c:v>
+                </c:pt>
+                <c:pt idx="77">
+                  <c:v>44742.0</c:v>
+                </c:pt>
+                <c:pt idx="78">
+                  <c:v>44773.0</c:v>
+                </c:pt>
+                <c:pt idx="79">
+                  <c:v>44804.0</c:v>
+                </c:pt>
+                <c:pt idx="80">
+                  <c:v>44834.0</c:v>
+                </c:pt>
+                <c:pt idx="81">
+                  <c:v>44865.0</c:v>
+                </c:pt>
+                <c:pt idx="82">
+                  <c:v>44895.0</c:v>
+                </c:pt>
+                <c:pt idx="83">
+                  <c:v>44926.0</c:v>
+                </c:pt>
+                <c:pt idx="84">
+                  <c:v>44957.0</c:v>
+                </c:pt>
+                <c:pt idx="85">
+                  <c:v>44985.0</c:v>
+                </c:pt>
+                <c:pt idx="86">
+                  <c:v>45016.0</c:v>
+                </c:pt>
+                <c:pt idx="87">
+                  <c:v>45046.0</c:v>
+                </c:pt>
+                <c:pt idx="88">
+                  <c:v>45077.0</c:v>
+                </c:pt>
+                <c:pt idx="89">
+                  <c:v>45107.0</c:v>
+                </c:pt>
+                <c:pt idx="90">
+                  <c:v>45138.0</c:v>
+                </c:pt>
+                <c:pt idx="91">
+                  <c:v>45169.0</c:v>
+                </c:pt>
+                <c:pt idx="92">
+                  <c:v>45199.0</c:v>
+                </c:pt>
+                <c:pt idx="93">
+                  <c:v>45230.0</c:v>
+                </c:pt>
+                <c:pt idx="94">
+                  <c:v>45260.0</c:v>
+                </c:pt>
+                <c:pt idx="95">
+                  <c:v>45291.0</c:v>
+                </c:pt>
+                <c:pt idx="96">
+                  <c:v>45322.0</c:v>
+                </c:pt>
+                <c:pt idx="97">
+                  <c:v>45351.0</c:v>
+                </c:pt>
+                <c:pt idx="98">
+                  <c:v>45382.0</c:v>
+                </c:pt>
+                <c:pt idx="99">
+                  <c:v>45412.0</c:v>
+                </c:pt>
+                <c:pt idx="100">
+                  <c:v>45443.0</c:v>
+                </c:pt>
+                <c:pt idx="101">
+                  <c:v>45473.0</c:v>
+                </c:pt>
+                <c:pt idx="102">
+                  <c:v>45504.0</c:v>
+                </c:pt>
+                <c:pt idx="103">
+                  <c:v>45535.0</c:v>
+                </c:pt>
+                <c:pt idx="104">
+                  <c:v>45565.0</c:v>
+                </c:pt>
+                <c:pt idx="105">
+                  <c:v>45596.0</c:v>
+                </c:pt>
+                <c:pt idx="106">
+                  <c:v>45626.0</c:v>
+                </c:pt>
+                <c:pt idx="107">
+                  <c:v>45657.0</c:v>
+                </c:pt>
+                <c:pt idx="108">
+                  <c:v>45688.0</c:v>
+                </c:pt>
+                <c:pt idx="109">
+                  <c:v>45716.0</c:v>
+                </c:pt>
+                <c:pt idx="110">
+                  <c:v>45747.0</c:v>
+                </c:pt>
+                <c:pt idx="111">
+                  <c:v>45777.0</c:v>
+                </c:pt>
+                <c:pt idx="112">
+                  <c:v>45808.0</c:v>
+                </c:pt>
+                <c:pt idx="113">
+                  <c:v>45838.0</c:v>
+                </c:pt>
+                <c:pt idx="114">
+                  <c:v>45869.0</c:v>
+                </c:pt>
+                <c:pt idx="115">
+                  <c:v>45900.0</c:v>
+                </c:pt>
+                <c:pt idx="116">
+                  <c:v>45930.0</c:v>
+                </c:pt>
+                <c:pt idx="117">
+                  <c:v>45961.0</c:v>
+                </c:pt>
+                <c:pt idx="118">
+                  <c:v>45991.0</c:v>
+                </c:pt>
+                <c:pt idx="119">
+                  <c:v>46022.0</c:v>
+                </c:pt>
+                <c:pt idx="120">
+                  <c:v>46053.0</c:v>
+                </c:pt>
+                <c:pt idx="121">
+                  <c:v>46081.0</c:v>
+                </c:pt>
+                <c:pt idx="122">
+                  <c:v>46112.0</c:v>
+                </c:pt>
+                <c:pt idx="123">
+                  <c:v>46142.0</c:v>
+                </c:pt>
+                <c:pt idx="124">
+                  <c:v>46173.0</c:v>
+                </c:pt>
+                <c:pt idx="125">
+                  <c:v>46203.0</c:v>
+                </c:pt>
+                <c:pt idx="126">
+                  <c:v>46234.0</c:v>
+                </c:pt>
+                <c:pt idx="127">
+                  <c:v>46265.0</c:v>
+                </c:pt>
+                <c:pt idx="128">
+                  <c:v>46295.0</c:v>
+                </c:pt>
+              </c:numCache>
+            </c:numRef>
           </c:cat>
           <c:val>
             <c:numRef>
-              <c:f>Sheet1!$B$2:$B$6</c:f>
+              <c:f>Sheet1!$B$2:$B$130</c:f>
               <c:numCache>
                 <c:formatCode>General</c:formatCode>
-                <c:ptCount val="5"/>
+                <c:ptCount val="129"/>
                 <c:pt idx="0">
-                  <c:v>0.583714381876387</c:v>
+                  <c:v>100230.39947940658</c:v>
                 </c:pt>
                 <c:pt idx="1">
-                  <c:v>0.9136048364421668</c:v>
+                  <c:v>102546.7823171292</c:v>
                 </c:pt>
                 <c:pt idx="2">
-                  <c:v>1.2197919163186426</c:v>
+                  <c:v>103947.55554813756</c:v>
                 </c:pt>
                 <c:pt idx="3">
-                  <c:v>1.1429236480955736</c:v>
+                  <c:v>103325.03030805245</c:v>
                 </c:pt>
                 <c:pt idx="4">
-                  <c:v>1.1187921289080605</c:v>
+                  <c:v>104091.94268347506</c:v>
+                </c:pt>
+                <c:pt idx="5">
+                  <c:v>103656.88410161564</c:v>
+                </c:pt>
+                <c:pt idx="6">
+                  <c:v>102926.55150471172</c:v>
+                </c:pt>
+                <c:pt idx="7">
+                  <c:v>101550.7933097614</c:v>
+                </c:pt>
+                <c:pt idx="8">
+                  <c:v>104397.68194884424</c:v>
+                </c:pt>
+                <c:pt idx="9">
+                  <c:v>103097.6827768544</c:v>
+                </c:pt>
+                <c:pt idx="10">
+                  <c:v>103694.7750795057</c:v>
+                </c:pt>
+                <c:pt idx="11">
+                  <c:v>104117.1520345038</c:v>
+                </c:pt>
+                <c:pt idx="12">
+                  <c:v>103003.5309973231</c:v>
+                </c:pt>
+                <c:pt idx="13">
+                  <c:v>102749.30415344932</c:v>
+                </c:pt>
+                <c:pt idx="14">
+                  <c:v>103064.78113368804</c:v>
+                </c:pt>
+                <c:pt idx="15">
+                  <c:v>101993.55830908894</c:v>
+                </c:pt>
+                <c:pt idx="16">
+                  <c:v>102849.0226703944</c:v>
+                </c:pt>
+                <c:pt idx="17">
+                  <c:v>105157.520589833</c:v>
+                </c:pt>
+                <c:pt idx="18">
+                  <c:v>104575.49381403557</c:v>
+                </c:pt>
+                <c:pt idx="19">
+                  <c:v>105953.76602301524</c:v>
+                </c:pt>
+                <c:pt idx="20">
+                  <c:v>105098.276014876</c:v>
+                </c:pt>
+                <c:pt idx="21">
+                  <c:v>105476.19444355388</c:v>
+                </c:pt>
+                <c:pt idx="22">
+                  <c:v>105518.8403795888</c:v>
+                </c:pt>
+                <c:pt idx="23">
+                  <c:v>103936.45291514974</c:v>
+                </c:pt>
+                <c:pt idx="24">
+                  <c:v>105248.27391777188</c:v>
+                </c:pt>
+                <c:pt idx="25">
+                  <c:v>107402.85239958204</c:v>
+                </c:pt>
+                <c:pt idx="26">
+                  <c:v>112576.88335707868</c:v>
+                </c:pt>
+                <c:pt idx="27">
+                  <c:v>115671.95371309444</c:v>
+                </c:pt>
+                <c:pt idx="28">
+                  <c:v>115020.98977958472</c:v>
+                </c:pt>
+                <c:pt idx="29">
+                  <c:v>114050.9797101094</c:v>
+                </c:pt>
+                <c:pt idx="30">
+                  <c:v>117948.26861637576</c:v>
+                </c:pt>
+                <c:pt idx="31">
+                  <c:v>117847.746504809</c:v>
+                </c:pt>
+                <c:pt idx="32">
+                  <c:v>117050.56817906268</c:v>
+                </c:pt>
+                <c:pt idx="33">
+                  <c:v>122810.28659651098</c:v>
+                </c:pt>
+                <c:pt idx="34">
+                  <c:v>127438.3491936226</c:v>
+                </c:pt>
+                <c:pt idx="35">
+                  <c:v>129527.4610236357</c:v>
+                </c:pt>
+                <c:pt idx="36">
+                  <c:v>129472.46811661006</c:v>
+                </c:pt>
+                <c:pt idx="37">
+                  <c:v>128462.23426271224</c:v>
+                </c:pt>
+                <c:pt idx="38">
+                  <c:v>128015.12127073092</c:v>
+                </c:pt>
+                <c:pt idx="39">
+                  <c:v>127315.1724998588</c:v>
+                </c:pt>
+                <c:pt idx="40">
+                  <c:v>125377.1028291904</c:v>
+                </c:pt>
+                <c:pt idx="41">
+                  <c:v>129043.39452527493</c:v>
+                </c:pt>
+                <c:pt idx="42">
+                  <c:v>127048.99272540864</c:v>
+                </c:pt>
+                <c:pt idx="43">
+                  <c:v>127494.18064284968</c:v>
+                </c:pt>
+                <c:pt idx="44">
+                  <c:v>128002.23882361052</c:v>
+                </c:pt>
+                <c:pt idx="45">
+                  <c:v>127189.27346151748</c:v>
+                </c:pt>
+                <c:pt idx="46">
+                  <c:v>125850.855601484</c:v>
+                </c:pt>
+                <c:pt idx="47">
+                  <c:v>125464.91772928293</c:v>
+                </c:pt>
+                <c:pt idx="48">
+                  <c:v>128004.10938850052</c:v>
+                </c:pt>
+                <c:pt idx="49">
+                  <c:v>131860.68163659316</c:v>
+                </c:pt>
+                <c:pt idx="50">
+                  <c:v>131804.79292741744</c:v>
+                </c:pt>
+                <c:pt idx="51">
+                  <c:v>133420.52004721007</c:v>
+                </c:pt>
+                <c:pt idx="52">
+                  <c:v>128675.02093830364</c:v>
+                </c:pt>
+                <c:pt idx="53">
+                  <c:v>133288.66285691183</c:v>
+                </c:pt>
+                <c:pt idx="54">
+                  <c:v>135289.54271799396</c:v>
+                </c:pt>
+                <c:pt idx="55">
+                  <c:v>136206.81495354295</c:v>
+                </c:pt>
+                <c:pt idx="56">
+                  <c:v>135841.5029705821</c:v>
+                </c:pt>
+                <c:pt idx="57">
+                  <c:v>137747.1125611876</c:v>
+                </c:pt>
+                <c:pt idx="58">
+                  <c:v>136059.5290209362</c:v>
+                </c:pt>
+                <c:pt idx="59">
+                  <c:v>134189.43119466898</c:v>
+                </c:pt>
+                <c:pt idx="60">
+                  <c:v>136531.54885101816</c:v>
+                </c:pt>
+                <c:pt idx="61">
+                  <c:v>134035.82173257257</c:v>
+                </c:pt>
+                <c:pt idx="62">
+                  <c:v>137666.56888928032</c:v>
+                </c:pt>
+                <c:pt idx="63">
+                  <c:v>138686.85579869125</c:v>
+                </c:pt>
+                <c:pt idx="64">
+                  <c:v>140822.646542011</c:v>
+                </c:pt>
+                <c:pt idx="65">
+                  <c:v>142143.09348957211</c:v>
+                </c:pt>
+                <c:pt idx="66">
+                  <c:v>143111.82601020316</c:v>
+                </c:pt>
+                <c:pt idx="67">
+                  <c:v>142268.99617050152</c:v>
+                </c:pt>
+                <c:pt idx="68">
+                  <c:v>141527.39857998988</c:v>
+                </c:pt>
+                <c:pt idx="69">
+                  <c:v>141625.4253337005</c:v>
+                </c:pt>
+                <c:pt idx="70">
+                  <c:v>140056.42952628084</c:v>
+                </c:pt>
+                <c:pt idx="71">
+                  <c:v>141274.53753445283</c:v>
+                </c:pt>
+                <c:pt idx="72">
+                  <c:v>141301.92281418177</c:v>
+                </c:pt>
+                <c:pt idx="73">
+                  <c:v>146413.3756814629</c:v>
+                </c:pt>
+                <c:pt idx="74">
+                  <c:v>145969.76549374245</c:v>
+                </c:pt>
+                <c:pt idx="75">
+                  <c:v>156614.14189593322</c:v>
+                </c:pt>
+                <c:pt idx="76">
+                  <c:v>163122.2717078227</c:v>
+                </c:pt>
+                <c:pt idx="77">
+                  <c:v>162606.11039081623</c:v>
+                </c:pt>
+                <c:pt idx="78">
+                  <c:v>162418.2185922516</c:v>
+                </c:pt>
+                <c:pt idx="79">
+                  <c:v>166769.86673902508</c:v>
+                </c:pt>
+                <c:pt idx="80">
+                  <c:v>165288.04195997005</c:v>
+                </c:pt>
+                <c:pt idx="81">
+                  <c:v>172110.15492937283</c:v>
+                </c:pt>
+                <c:pt idx="82">
+                  <c:v>173364.59359607426</c:v>
+                </c:pt>
+                <c:pt idx="83">
+                  <c:v>174076.45110547726</c:v>
+                </c:pt>
+                <c:pt idx="84">
+                  <c:v>176232.93618715453</c:v>
+                </c:pt>
+                <c:pt idx="85">
+                  <c:v>176506.2519990013</c:v>
+                </c:pt>
+                <c:pt idx="86">
+                  <c:v>175657.18566114389</c:v>
+                </c:pt>
+                <c:pt idx="87">
+                  <c:v>180072.41662659566</c:v>
+                </c:pt>
+                <c:pt idx="88">
+                  <c:v>183487.10322394944</c:v>
+                </c:pt>
+                <c:pt idx="89">
+                  <c:v>185975.36461468163</c:v>
+                </c:pt>
+                <c:pt idx="90">
+                  <c:v>185892.5279498607</c:v>
+                </c:pt>
+                <c:pt idx="91">
+                  <c:v>193151.1204036529</c:v>
+                </c:pt>
+                <c:pt idx="92">
+                  <c:v>192569.84798474849</c:v>
+                </c:pt>
+                <c:pt idx="93">
+                  <c:v>192246.98443883596</c:v>
+                </c:pt>
+                <c:pt idx="94">
+                  <c:v>195031.13602507176</c:v>
+                </c:pt>
+                <c:pt idx="95">
+                  <c:v>193227.82284112857</c:v>
+                </c:pt>
+                <c:pt idx="96">
+                  <c:v>194966.22585436428</c:v>
+                </c:pt>
+                <c:pt idx="97">
+                  <c:v>194027.1572201521</c:v>
+                </c:pt>
+                <c:pt idx="98">
+                  <c:v>194668.83234591645</c:v>
+                </c:pt>
+                <c:pt idx="99">
+                  <c:v>200190.2416207173</c:v>
+                </c:pt>
+                <c:pt idx="100">
+                  <c:v>200511.319088194</c:v>
+                </c:pt>
+                <c:pt idx="101">
+                  <c:v>199315.72326061892</c:v>
+                </c:pt>
+                <c:pt idx="102">
+                  <c:v>206630.83617246957</c:v>
+                </c:pt>
+                <c:pt idx="103">
+                  <c:v>203851.53159335672</c:v>
+                </c:pt>
+                <c:pt idx="104">
+                  <c:v>208215.9058974939</c:v>
+                </c:pt>
+                <c:pt idx="105">
+                  <c:v>210162.859984172</c:v>
+                </c:pt>
+                <c:pt idx="106">
+                  <c:v>209619.47419579263</c:v>
+                </c:pt>
+                <c:pt idx="107">
+                  <c:v>215463.44826390425</c:v>
+                </c:pt>
+                <c:pt idx="108">
+                  <c:v>216480.83683827583</c:v>
+                </c:pt>
+                <c:pt idx="109">
+                  <c:v>220310.695378724</c:v>
+                </c:pt>
+                <c:pt idx="110">
+                  <c:v>219346.91773716427</c:v>
+                </c:pt>
+                <c:pt idx="111">
+                  <c:v>237974.497919664</c:v>
+                </c:pt>
+                <c:pt idx="112">
+                  <c:v>235399.0154224078</c:v>
+                </c:pt>
+                <c:pt idx="113">
+                  <c:v>232341.95300305035</c:v>
+                </c:pt>
+                <c:pt idx="114">
+                  <c:v>228015.19180416275</c:v>
+                </c:pt>
+                <c:pt idx="115">
+                  <c:v>227305.90649706768</c:v>
+                </c:pt>
+                <c:pt idx="116">
+                  <c:v>223013.74559977</c:v>
+                </c:pt>
+                <c:pt idx="117">
+                  <c:v>226086.0070218788</c:v>
+                </c:pt>
+                <c:pt idx="118">
+                  <c:v>229482.81031777355</c:v>
+                </c:pt>
+                <c:pt idx="119">
+                  <c:v>227470.31880532423</c:v>
+                </c:pt>
+                <c:pt idx="120">
+                  <c:v>220046.0131322749</c:v>
+                </c:pt>
+                <c:pt idx="121">
+                  <c:v>222802.13191967792</c:v>
+                </c:pt>
+                <c:pt idx="122">
+                  <c:v>227890.84218614615</c:v>
+                </c:pt>
+                <c:pt idx="123">
+                  <c:v>226494.10630389227</c:v>
+                </c:pt>
+                <c:pt idx="124">
+                  <c:v>226305.12466129437</c:v>
+                </c:pt>
+                <c:pt idx="125">
+                  <c:v>232859.1915923143</c:v>
+                </c:pt>
+                <c:pt idx="126">
+                  <c:v>228492.65426880596</c:v>
+                </c:pt>
+                <c:pt idx="127">
+                  <c:v>231253.23260907148</c:v>
+                </c:pt>
+                <c:pt idx="128">
+                  <c:v>231207.08099815168</c:v>
                 </c:pt>
               </c:numCache>
             </c:numRef>
           </c:val>
+          <c:smooth val="0"/>
         </c:ser>
         <c:ser>
           <c:idx val="1"/>
@@ -8302,98 +9052,1649 @@
               <c:strCache>
                 <c:ptCount val="1"/>
                 <c:pt idx="0">
-                  <c:v>SPY</c:v>
+                  <c:v>SPY  (+45,550)</c:v>
                 </c:pt>
               </c:strCache>
             </c:strRef>
           </c:tx>
           <c:spPr>
-            <a:solidFill>
-              <a:srgbClr val="0B1F3A"/>
-            </a:solidFill>
+            <a:ln w="22225">
+              <a:solidFill>
+                <a:srgbClr val="0B1F3A"/>
+              </a:solidFill>
+            </a:ln>
           </c:spPr>
-          <c:invertIfNegative val="0"/>
+          <c:marker>
+            <c:symbol val="none"/>
+          </c:marker>
           <c:cat>
-            <c:strRef>
-              <c:f>Sheet1!$A$2:$A$6</c:f>
-              <c:strCache>
-                <c:ptCount val="5"/>
+            <c:numRef>
+              <c:f>Sheet1!$A$2:$A$130</c:f>
+              <c:numCache>
+                <c:formatCode>yyyy\-mm\-dd</c:formatCode>
+                <c:ptCount val="129"/>
                 <c:pt idx="0">
-                  <c:v>5 min</c:v>
+                  <c:v>42400.0</c:v>
                 </c:pt>
                 <c:pt idx="1">
-                  <c:v>15 min</c:v>
+                  <c:v>42429.0</c:v>
                 </c:pt>
                 <c:pt idx="2">
-                  <c:v>30 min</c:v>
+                  <c:v>42460.0</c:v>
                 </c:pt>
                 <c:pt idx="3">
-                  <c:v>60 min</c:v>
+                  <c:v>42490.0</c:v>
                 </c:pt>
                 <c:pt idx="4">
-                  <c:v>30 + 5-min stop</c:v>
-                </c:pt>
-              </c:strCache>
-            </c:strRef>
+                  <c:v>42521.0</c:v>
+                </c:pt>
+                <c:pt idx="5">
+                  <c:v>42551.0</c:v>
+                </c:pt>
+                <c:pt idx="6">
+                  <c:v>42582.0</c:v>
+                </c:pt>
+                <c:pt idx="7">
+                  <c:v>42613.0</c:v>
+                </c:pt>
+                <c:pt idx="8">
+                  <c:v>42643.0</c:v>
+                </c:pt>
+                <c:pt idx="9">
+                  <c:v>42674.0</c:v>
+                </c:pt>
+                <c:pt idx="10">
+                  <c:v>42704.0</c:v>
+                </c:pt>
+                <c:pt idx="11">
+                  <c:v>42735.0</c:v>
+                </c:pt>
+                <c:pt idx="12">
+                  <c:v>42766.0</c:v>
+                </c:pt>
+                <c:pt idx="13">
+                  <c:v>42794.0</c:v>
+                </c:pt>
+                <c:pt idx="14">
+                  <c:v>42825.0</c:v>
+                </c:pt>
+                <c:pt idx="15">
+                  <c:v>42855.0</c:v>
+                </c:pt>
+                <c:pt idx="16">
+                  <c:v>42886.0</c:v>
+                </c:pt>
+                <c:pt idx="17">
+                  <c:v>42916.0</c:v>
+                </c:pt>
+                <c:pt idx="18">
+                  <c:v>42947.0</c:v>
+                </c:pt>
+                <c:pt idx="19">
+                  <c:v>42978.0</c:v>
+                </c:pt>
+                <c:pt idx="20">
+                  <c:v>43008.0</c:v>
+                </c:pt>
+                <c:pt idx="21">
+                  <c:v>43039.0</c:v>
+                </c:pt>
+                <c:pt idx="22">
+                  <c:v>43069.0</c:v>
+                </c:pt>
+                <c:pt idx="23">
+                  <c:v>43100.0</c:v>
+                </c:pt>
+                <c:pt idx="24">
+                  <c:v>43131.0</c:v>
+                </c:pt>
+                <c:pt idx="25">
+                  <c:v>43159.0</c:v>
+                </c:pt>
+                <c:pt idx="26">
+                  <c:v>43190.0</c:v>
+                </c:pt>
+                <c:pt idx="27">
+                  <c:v>43220.0</c:v>
+                </c:pt>
+                <c:pt idx="28">
+                  <c:v>43251.0</c:v>
+                </c:pt>
+                <c:pt idx="29">
+                  <c:v>43281.0</c:v>
+                </c:pt>
+                <c:pt idx="30">
+                  <c:v>43312.0</c:v>
+                </c:pt>
+                <c:pt idx="31">
+                  <c:v>43343.0</c:v>
+                </c:pt>
+                <c:pt idx="32">
+                  <c:v>43373.0</c:v>
+                </c:pt>
+                <c:pt idx="33">
+                  <c:v>43404.0</c:v>
+                </c:pt>
+                <c:pt idx="34">
+                  <c:v>43434.0</c:v>
+                </c:pt>
+                <c:pt idx="35">
+                  <c:v>43465.0</c:v>
+                </c:pt>
+                <c:pt idx="36">
+                  <c:v>43496.0</c:v>
+                </c:pt>
+                <c:pt idx="37">
+                  <c:v>43524.0</c:v>
+                </c:pt>
+                <c:pt idx="38">
+                  <c:v>43555.0</c:v>
+                </c:pt>
+                <c:pt idx="39">
+                  <c:v>43585.0</c:v>
+                </c:pt>
+                <c:pt idx="40">
+                  <c:v>43616.0</c:v>
+                </c:pt>
+                <c:pt idx="41">
+                  <c:v>43646.0</c:v>
+                </c:pt>
+                <c:pt idx="42">
+                  <c:v>43677.0</c:v>
+                </c:pt>
+                <c:pt idx="43">
+                  <c:v>43708.0</c:v>
+                </c:pt>
+                <c:pt idx="44">
+                  <c:v>43738.0</c:v>
+                </c:pt>
+                <c:pt idx="45">
+                  <c:v>43769.0</c:v>
+                </c:pt>
+                <c:pt idx="46">
+                  <c:v>43799.0</c:v>
+                </c:pt>
+                <c:pt idx="47">
+                  <c:v>43830.0</c:v>
+                </c:pt>
+                <c:pt idx="48">
+                  <c:v>43861.0</c:v>
+                </c:pt>
+                <c:pt idx="49">
+                  <c:v>43890.0</c:v>
+                </c:pt>
+                <c:pt idx="50">
+                  <c:v>43921.0</c:v>
+                </c:pt>
+                <c:pt idx="51">
+                  <c:v>43951.0</c:v>
+                </c:pt>
+                <c:pt idx="52">
+                  <c:v>43982.0</c:v>
+                </c:pt>
+                <c:pt idx="53">
+                  <c:v>44012.0</c:v>
+                </c:pt>
+                <c:pt idx="54">
+                  <c:v>44043.0</c:v>
+                </c:pt>
+                <c:pt idx="55">
+                  <c:v>44074.0</c:v>
+                </c:pt>
+                <c:pt idx="56">
+                  <c:v>44104.0</c:v>
+                </c:pt>
+                <c:pt idx="57">
+                  <c:v>44135.0</c:v>
+                </c:pt>
+                <c:pt idx="58">
+                  <c:v>44165.0</c:v>
+                </c:pt>
+                <c:pt idx="59">
+                  <c:v>44196.0</c:v>
+                </c:pt>
+                <c:pt idx="60">
+                  <c:v>44227.0</c:v>
+                </c:pt>
+                <c:pt idx="61">
+                  <c:v>44255.0</c:v>
+                </c:pt>
+                <c:pt idx="62">
+                  <c:v>44286.0</c:v>
+                </c:pt>
+                <c:pt idx="63">
+                  <c:v>44316.0</c:v>
+                </c:pt>
+                <c:pt idx="64">
+                  <c:v>44347.0</c:v>
+                </c:pt>
+                <c:pt idx="65">
+                  <c:v>44377.0</c:v>
+                </c:pt>
+                <c:pt idx="66">
+                  <c:v>44408.0</c:v>
+                </c:pt>
+                <c:pt idx="67">
+                  <c:v>44439.0</c:v>
+                </c:pt>
+                <c:pt idx="68">
+                  <c:v>44469.0</c:v>
+                </c:pt>
+                <c:pt idx="69">
+                  <c:v>44500.0</c:v>
+                </c:pt>
+                <c:pt idx="70">
+                  <c:v>44530.0</c:v>
+                </c:pt>
+                <c:pt idx="71">
+                  <c:v>44561.0</c:v>
+                </c:pt>
+                <c:pt idx="72">
+                  <c:v>44592.0</c:v>
+                </c:pt>
+                <c:pt idx="73">
+                  <c:v>44620.0</c:v>
+                </c:pt>
+                <c:pt idx="74">
+                  <c:v>44651.0</c:v>
+                </c:pt>
+                <c:pt idx="75">
+                  <c:v>44681.0</c:v>
+                </c:pt>
+                <c:pt idx="76">
+                  <c:v>44712.0</c:v>
+                </c:pt>
+                <c:pt idx="77">
+                  <c:v>44742.0</c:v>
+                </c:pt>
+                <c:pt idx="78">
+                  <c:v>44773.0</c:v>
+                </c:pt>
+                <c:pt idx="79">
+                  <c:v>44804.0</c:v>
+                </c:pt>
+                <c:pt idx="80">
+                  <c:v>44834.0</c:v>
+                </c:pt>
+                <c:pt idx="81">
+                  <c:v>44865.0</c:v>
+                </c:pt>
+                <c:pt idx="82">
+                  <c:v>44895.0</c:v>
+                </c:pt>
+                <c:pt idx="83">
+                  <c:v>44926.0</c:v>
+                </c:pt>
+                <c:pt idx="84">
+                  <c:v>44957.0</c:v>
+                </c:pt>
+                <c:pt idx="85">
+                  <c:v>44985.0</c:v>
+                </c:pt>
+                <c:pt idx="86">
+                  <c:v>45016.0</c:v>
+                </c:pt>
+                <c:pt idx="87">
+                  <c:v>45046.0</c:v>
+                </c:pt>
+                <c:pt idx="88">
+                  <c:v>45077.0</c:v>
+                </c:pt>
+                <c:pt idx="89">
+                  <c:v>45107.0</c:v>
+                </c:pt>
+                <c:pt idx="90">
+                  <c:v>45138.0</c:v>
+                </c:pt>
+                <c:pt idx="91">
+                  <c:v>45169.0</c:v>
+                </c:pt>
+                <c:pt idx="92">
+                  <c:v>45199.0</c:v>
+                </c:pt>
+                <c:pt idx="93">
+                  <c:v>45230.0</c:v>
+                </c:pt>
+                <c:pt idx="94">
+                  <c:v>45260.0</c:v>
+                </c:pt>
+                <c:pt idx="95">
+                  <c:v>45291.0</c:v>
+                </c:pt>
+                <c:pt idx="96">
+                  <c:v>45322.0</c:v>
+                </c:pt>
+                <c:pt idx="97">
+                  <c:v>45351.0</c:v>
+                </c:pt>
+                <c:pt idx="98">
+                  <c:v>45382.0</c:v>
+                </c:pt>
+                <c:pt idx="99">
+                  <c:v>45412.0</c:v>
+                </c:pt>
+                <c:pt idx="100">
+                  <c:v>45443.0</c:v>
+                </c:pt>
+                <c:pt idx="101">
+                  <c:v>45473.0</c:v>
+                </c:pt>
+                <c:pt idx="102">
+                  <c:v>45504.0</c:v>
+                </c:pt>
+                <c:pt idx="103">
+                  <c:v>45535.0</c:v>
+                </c:pt>
+                <c:pt idx="104">
+                  <c:v>45565.0</c:v>
+                </c:pt>
+                <c:pt idx="105">
+                  <c:v>45596.0</c:v>
+                </c:pt>
+                <c:pt idx="106">
+                  <c:v>45626.0</c:v>
+                </c:pt>
+                <c:pt idx="107">
+                  <c:v>45657.0</c:v>
+                </c:pt>
+                <c:pt idx="108">
+                  <c:v>45688.0</c:v>
+                </c:pt>
+                <c:pt idx="109">
+                  <c:v>45716.0</c:v>
+                </c:pt>
+                <c:pt idx="110">
+                  <c:v>45747.0</c:v>
+                </c:pt>
+                <c:pt idx="111">
+                  <c:v>45777.0</c:v>
+                </c:pt>
+                <c:pt idx="112">
+                  <c:v>45808.0</c:v>
+                </c:pt>
+                <c:pt idx="113">
+                  <c:v>45838.0</c:v>
+                </c:pt>
+                <c:pt idx="114">
+                  <c:v>45869.0</c:v>
+                </c:pt>
+                <c:pt idx="115">
+                  <c:v>45900.0</c:v>
+                </c:pt>
+                <c:pt idx="116">
+                  <c:v>45930.0</c:v>
+                </c:pt>
+                <c:pt idx="117">
+                  <c:v>45961.0</c:v>
+                </c:pt>
+                <c:pt idx="118">
+                  <c:v>45991.0</c:v>
+                </c:pt>
+                <c:pt idx="119">
+                  <c:v>46022.0</c:v>
+                </c:pt>
+                <c:pt idx="120">
+                  <c:v>46053.0</c:v>
+                </c:pt>
+                <c:pt idx="121">
+                  <c:v>46081.0</c:v>
+                </c:pt>
+                <c:pt idx="122">
+                  <c:v>46112.0</c:v>
+                </c:pt>
+                <c:pt idx="123">
+                  <c:v>46142.0</c:v>
+                </c:pt>
+                <c:pt idx="124">
+                  <c:v>46173.0</c:v>
+                </c:pt>
+                <c:pt idx="125">
+                  <c:v>46203.0</c:v>
+                </c:pt>
+                <c:pt idx="126">
+                  <c:v>46234.0</c:v>
+                </c:pt>
+                <c:pt idx="127">
+                  <c:v>46265.0</c:v>
+                </c:pt>
+                <c:pt idx="128">
+                  <c:v>46295.0</c:v>
+                </c:pt>
+              </c:numCache>
+            </c:numRef>
           </c:cat>
           <c:val>
             <c:numRef>
-              <c:f>Sheet1!$C$2:$C$6</c:f>
+              <c:f>Sheet1!$C$2:$C$130</c:f>
               <c:numCache>
                 <c:formatCode>General</c:formatCode>
-                <c:ptCount val="5"/>
+                <c:ptCount val="129"/>
                 <c:pt idx="0">
-                  <c:v>-0.1608217248160635</c:v>
+                  <c:v>98954.37846430478</c:v>
                 </c:pt>
                 <c:pt idx="1">
-                  <c:v>0.2918482399820949</c:v>
+                  <c:v>96409.84488677024</c:v>
                 </c:pt>
                 <c:pt idx="2">
-                  <c:v>0.6261527905209967</c:v>
+                  <c:v>96392.3021103848</c:v>
                 </c:pt>
                 <c:pt idx="3">
-                  <c:v>0.6601459905512106</c:v>
+                  <c:v>95672.26830474148</c:v>
                 </c:pt>
                 <c:pt idx="4">
-                  <c:v>0.6458297868145539</c:v>
+                  <c:v>96297.72041869765</c:v>
+                </c:pt>
+                <c:pt idx="5">
+                  <c:v>95679.59776803452</c:v>
+                </c:pt>
+                <c:pt idx="6">
+                  <c:v>94722.02512096522</c:v>
+                </c:pt>
+                <c:pt idx="7">
+                  <c:v>93851.26328723444</c:v>
+                </c:pt>
+                <c:pt idx="8">
+                  <c:v>95383.98393453869</c:v>
+                </c:pt>
+                <c:pt idx="9">
+                  <c:v>94499.81727456406</c:v>
+                </c:pt>
+                <c:pt idx="10">
+                  <c:v>94911.23032858876</c:v>
+                </c:pt>
+                <c:pt idx="11">
+                  <c:v>94134.156099483</c:v>
+                </c:pt>
+                <c:pt idx="12">
+                  <c:v>93383.40154489897</c:v>
+                </c:pt>
+                <c:pt idx="13">
+                  <c:v>93351.89830254445</c:v>
+                </c:pt>
+                <c:pt idx="14">
+                  <c:v>94235.70414384206</c:v>
+                </c:pt>
+                <c:pt idx="15">
+                  <c:v>93177.21823395503</c:v>
+                </c:pt>
+                <c:pt idx="16">
+                  <c:v>92209.32420121852</c:v>
+                </c:pt>
+                <c:pt idx="17">
+                  <c:v>91675.30122891124</c:v>
+                </c:pt>
+                <c:pt idx="18">
+                  <c:v>91059.8847696015</c:v>
+                </c:pt>
+                <c:pt idx="19">
+                  <c:v>92165.58432627174</c:v>
+                </c:pt>
+                <c:pt idx="20">
+                  <c:v>91688.37670798728</c:v>
+                </c:pt>
+                <c:pt idx="21">
+                  <c:v>92391.12376972025</c:v>
+                </c:pt>
+                <c:pt idx="22">
+                  <c:v>91986.39809543564</c:v>
+                </c:pt>
+                <c:pt idx="23">
+                  <c:v>90223.65758454424</c:v>
+                </c:pt>
+                <c:pt idx="24">
+                  <c:v>90693.2462721329</c:v>
+                </c:pt>
+                <c:pt idx="25">
+                  <c:v>94160.67193300654</c:v>
+                </c:pt>
+                <c:pt idx="26">
+                  <c:v>98222.68969824656</c:v>
+                </c:pt>
+                <c:pt idx="27">
+                  <c:v>99898.09609532647</c:v>
+                </c:pt>
+                <c:pt idx="28">
+                  <c:v>98503.19481235831</c:v>
+                </c:pt>
+                <c:pt idx="29">
+                  <c:v>98888.44765545629</c:v>
+                </c:pt>
+                <c:pt idx="30">
+                  <c:v>99504.93986589852</c:v>
+                </c:pt>
+                <c:pt idx="31">
+                  <c:v>98581.28837050394</c:v>
+                </c:pt>
+                <c:pt idx="32">
+                  <c:v>97967.77134156408</c:v>
+                </c:pt>
+                <c:pt idx="33">
+                  <c:v>101531.53898827136</c:v>
+                </c:pt>
+                <c:pt idx="34">
+                  <c:v>102703.03572078174</c:v>
+                </c:pt>
+                <c:pt idx="35">
+                  <c:v>109215.2509727668</c:v>
+                </c:pt>
+                <c:pt idx="36">
+                  <c:v>107889.60404297795</c:v>
+                </c:pt>
+                <c:pt idx="37">
+                  <c:v>107115.17795392296</c:v>
+                </c:pt>
+                <c:pt idx="38">
+                  <c:v>107818.85517845913</c:v>
+                </c:pt>
+                <c:pt idx="39">
+                  <c:v>107403.73417085456</c:v>
+                </c:pt>
+                <c:pt idx="40">
+                  <c:v>105262.26847472633</c:v>
+                </c:pt>
+                <c:pt idx="41">
+                  <c:v>105445.8429526694</c:v>
+                </c:pt>
+                <c:pt idx="42">
+                  <c:v>105305.75438005128</c:v>
+                </c:pt>
+                <c:pt idx="43">
+                  <c:v>107790.7947497</c:v>
+                </c:pt>
+                <c:pt idx="44">
+                  <c:v>106915.37713610171</c:v>
+                </c:pt>
+                <c:pt idx="45">
+                  <c:v>107415.87322967146</c:v>
+                </c:pt>
+                <c:pt idx="46">
+                  <c:v>106559.25826446449</c:v>
+                </c:pt>
+                <c:pt idx="47">
+                  <c:v>106753.65750108872</c:v>
+                </c:pt>
+                <c:pt idx="48">
+                  <c:v>108170.58417762475</c:v>
+                </c:pt>
+                <c:pt idx="49">
+                  <c:v>108107.7164283898</c:v>
+                </c:pt>
+                <c:pt idx="50">
+                  <c:v>105498.77178661256</c:v>
+                </c:pt>
+                <c:pt idx="51">
+                  <c:v>103507.23402615591</c:v>
+                </c:pt>
+                <c:pt idx="52">
+                  <c:v>102719.72755472956</c:v>
+                </c:pt>
+                <c:pt idx="53">
+                  <c:v>105954.7797876051</c:v>
+                </c:pt>
+                <c:pt idx="54">
+                  <c:v>104971.57171028586</c:v>
+                </c:pt>
+                <c:pt idx="55">
+                  <c:v>105050.74580898322</c:v>
+                </c:pt>
+                <c:pt idx="56">
+                  <c:v>108278.81554282516</c:v>
+                </c:pt>
+                <c:pt idx="57">
+                  <c:v>109086.28501742006</c:v>
+                </c:pt>
+                <c:pt idx="58">
+                  <c:v>108339.72646006962</c:v>
+                </c:pt>
+                <c:pt idx="59">
+                  <c:v>108237.0609644746</c:v>
+                </c:pt>
+                <c:pt idx="60">
+                  <c:v>109967.5670519048</c:v>
+                </c:pt>
+                <c:pt idx="61">
+                  <c:v>110740.6942126216</c:v>
+                </c:pt>
+                <c:pt idx="62">
+                  <c:v>111806.66696594452</c:v>
+                </c:pt>
+                <c:pt idx="63">
+                  <c:v>113497.7286023056</c:v>
+                </c:pt>
+                <c:pt idx="64">
+                  <c:v>115258.54614977364</c:v>
+                </c:pt>
+                <c:pt idx="65">
+                  <c:v>115676.45680141152</c:v>
+                </c:pt>
+                <c:pt idx="66">
+                  <c:v>116391.57995472135</c:v>
+                </c:pt>
+                <c:pt idx="67">
+                  <c:v>116562.3835500071</c:v>
+                </c:pt>
+                <c:pt idx="68">
+                  <c:v>117680.7269853022</c:v>
+                </c:pt>
+                <c:pt idx="69">
+                  <c:v>118993.24254089124</c:v>
+                </c:pt>
+                <c:pt idx="70">
+                  <c:v>118445.8123396472</c:v>
+                </c:pt>
+                <c:pt idx="71">
+                  <c:v>119163.58548013568</c:v>
+                </c:pt>
+                <c:pt idx="72">
+                  <c:v>117608.50621443466</c:v>
+                </c:pt>
+                <c:pt idx="73">
+                  <c:v>120632.8649150764</c:v>
+                </c:pt>
+                <c:pt idx="74">
+                  <c:v>120667.93044862807</c:v>
+                </c:pt>
+                <c:pt idx="75">
+                  <c:v>127112.78131063626</c:v>
+                </c:pt>
+                <c:pt idx="76">
+                  <c:v>128944.01587221194</c:v>
+                </c:pt>
+                <c:pt idx="77">
+                  <c:v>129584.64832657955</c:v>
+                </c:pt>
+                <c:pt idx="78">
+                  <c:v>128729.71484383456</c:v>
+                </c:pt>
+                <c:pt idx="79">
+                  <c:v>132480.25498558508</c:v>
+                </c:pt>
+                <c:pt idx="80">
+                  <c:v>131363.7729546764</c:v>
+                </c:pt>
+                <c:pt idx="81">
+                  <c:v>137602.77465162726</c:v>
+                </c:pt>
+                <c:pt idx="82">
+                  <c:v>139340.70109419376</c:v>
+                </c:pt>
+                <c:pt idx="83">
+                  <c:v>141489.36430266118</c:v>
+                </c:pt>
+                <c:pt idx="84">
+                  <c:v>142855.55662277804</c:v>
+                </c:pt>
+                <c:pt idx="85">
+                  <c:v>141769.34776951562</c:v>
+                </c:pt>
+                <c:pt idx="86">
+                  <c:v>144527.07834359817</c:v>
+                </c:pt>
+                <c:pt idx="87">
+                  <c:v>145595.2630560904</c:v>
+                </c:pt>
+                <c:pt idx="88">
+                  <c:v>147390.3968476642</c:v>
+                </c:pt>
+                <c:pt idx="89">
+                  <c:v>149425.04067036865</c:v>
+                </c:pt>
+                <c:pt idx="90">
+                  <c:v>149789.65011717257</c:v>
+                </c:pt>
+                <c:pt idx="91">
+                  <c:v>152730.79236740785</c:v>
+                </c:pt>
+                <c:pt idx="92">
+                  <c:v>152352.8813347849</c:v>
+                </c:pt>
+                <c:pt idx="93">
+                  <c:v>150144.8461552677</c:v>
+                </c:pt>
+                <c:pt idx="94">
+                  <c:v>151058.2852994639</c:v>
+                </c:pt>
+                <c:pt idx="95">
+                  <c:v>151069.92648213552</c:v>
+                </c:pt>
+                <c:pt idx="96">
+                  <c:v>152891.56540229084</c:v>
+                </c:pt>
+                <c:pt idx="97">
+                  <c:v>152471.6819521312</c:v>
+                </c:pt>
+                <c:pt idx="98">
+                  <c:v>151148.56913406</c:v>
+                </c:pt>
+                <c:pt idx="99">
+                  <c:v>153119.06096731676</c:v>
+                </c:pt>
+                <c:pt idx="100">
+                  <c:v>151502.67150196436</c:v>
+                </c:pt>
+                <c:pt idx="101">
+                  <c:v>151285.49382825004</c:v>
+                </c:pt>
+                <c:pt idx="102">
+                  <c:v>151938.36715944213</c:v>
+                </c:pt>
+                <c:pt idx="103">
+                  <c:v>150631.86829924394</c:v>
+                </c:pt>
+                <c:pt idx="104">
+                  <c:v>153390.79375778913</c:v>
+                </c:pt>
+                <c:pt idx="105">
+                  <c:v>155737.6034142902</c:v>
+                </c:pt>
+                <c:pt idx="106">
+                  <c:v>154087.9988951543</c:v>
+                </c:pt>
+                <c:pt idx="107">
+                  <c:v>155367.72459371007</c:v>
+                </c:pt>
+                <c:pt idx="108">
+                  <c:v>153551.05156624617</c:v>
+                </c:pt>
+                <c:pt idx="109">
+                  <c:v>155952.4171484238</c:v>
+                </c:pt>
+                <c:pt idx="110">
+                  <c:v>154138.68832878594</c:v>
+                </c:pt>
+                <c:pt idx="111">
+                  <c:v>159505.16065532225</c:v>
+                </c:pt>
+                <c:pt idx="112">
+                  <c:v>158220.5649640813</c:v>
+                </c:pt>
+                <c:pt idx="113">
+                  <c:v>157537.99882229976</c:v>
+                </c:pt>
+                <c:pt idx="114">
+                  <c:v>156704.39946816125</c:v>
+                </c:pt>
+                <c:pt idx="115">
+                  <c:v>156631.8475733726</c:v>
+                </c:pt>
+                <c:pt idx="116">
+                  <c:v>154766.0124230207</c:v>
+                </c:pt>
+                <c:pt idx="117">
+                  <c:v>155928.08804062687</c:v>
+                </c:pt>
+                <c:pt idx="118">
+                  <c:v>155313.845371916</c:v>
+                </c:pt>
+                <c:pt idx="119">
+                  <c:v>155550.20443074682</c:v>
+                </c:pt>
+                <c:pt idx="120">
+                  <c:v>153665.24560789758</c:v>
+                </c:pt>
+                <c:pt idx="121">
+                  <c:v>152367.54964717006</c:v>
+                </c:pt>
+                <c:pt idx="122">
+                  <c:v>152291.9236050696</c:v>
+                </c:pt>
+                <c:pt idx="123">
+                  <c:v>150629.52856463875</c:v>
+                </c:pt>
+                <c:pt idx="124">
+                  <c:v>148501.23930085776</c:v>
+                </c:pt>
+                <c:pt idx="125">
+                  <c:v>149181.5554670439</c:v>
+                </c:pt>
+                <c:pt idx="126">
+                  <c:v>146185.26556351667</c:v>
+                </c:pt>
+                <c:pt idx="127">
+                  <c:v>147092.49444076617</c:v>
+                </c:pt>
+                <c:pt idx="128">
+                  <c:v>145549.7547475756</c:v>
                 </c:pt>
               </c:numCache>
             </c:numRef>
           </c:val>
+          <c:smooth val="0"/>
         </c:ser>
-        <c:dLbls>
-          <c:numFmt formatCode="0.00" sourceLinked="0"/>
-          <c:txPr>
-            <a:bodyPr/>
-            <a:lstStyle/>
-            <a:p>
-              <a:pPr>
-                <a:defRPr sz="1000"/>
-              </a:pPr>
-            </a:p>
-          </c:txPr>
-          <c:showLegendKey val="0"/>
-          <c:showVal val="1"/>
-          <c:showCatName val="0"/>
-          <c:showSerName val="0"/>
-          <c:showPercent val="0"/>
-          <c:showBubbleSize val="0"/>
-          <c:showLeaderLines val="1"/>
-        </c:dLbls>
-        <c:gapWidth val="60"/>
-        <c:axId val="-2068027336"/>
-        <c:axId val="-2113994440"/>
-      </c:barChart>
-      <c:catAx>
-        <c:axId val="-2068027336"/>
+        <c:ser>
+          <c:idx val="2"/>
+          <c:order val="2"/>
+          <c:tx>
+            <c:strRef>
+              <c:f>Sheet1!$D$1</c:f>
+              <c:strCache>
+                <c:ptCount val="1"/>
+                <c:pt idx="0">
+                  <c:v>the bot's book: 50% QQQ + 50% SPY  (+84,140)</c:v>
+                </c:pt>
+              </c:strCache>
+            </c:strRef>
+          </c:tx>
+          <c:spPr>
+            <a:ln w="31750">
+              <a:solidFill>
+                <a:srgbClr val="2E8B57"/>
+              </a:solidFill>
+            </a:ln>
+          </c:spPr>
+          <c:marker>
+            <c:symbol val="none"/>
+          </c:marker>
+          <c:cat>
+            <c:numRef>
+              <c:f>Sheet1!$A$2:$A$130</c:f>
+              <c:numCache>
+                <c:formatCode>yyyy\-mm\-dd</c:formatCode>
+                <c:ptCount val="129"/>
+                <c:pt idx="0">
+                  <c:v>42400.0</c:v>
+                </c:pt>
+                <c:pt idx="1">
+                  <c:v>42429.0</c:v>
+                </c:pt>
+                <c:pt idx="2">
+                  <c:v>42460.0</c:v>
+                </c:pt>
+                <c:pt idx="3">
+                  <c:v>42490.0</c:v>
+                </c:pt>
+                <c:pt idx="4">
+                  <c:v>42521.0</c:v>
+                </c:pt>
+                <c:pt idx="5">
+                  <c:v>42551.0</c:v>
+                </c:pt>
+                <c:pt idx="6">
+                  <c:v>42582.0</c:v>
+                </c:pt>
+                <c:pt idx="7">
+                  <c:v>42613.0</c:v>
+                </c:pt>
+                <c:pt idx="8">
+                  <c:v>42643.0</c:v>
+                </c:pt>
+                <c:pt idx="9">
+                  <c:v>42674.0</c:v>
+                </c:pt>
+                <c:pt idx="10">
+                  <c:v>42704.0</c:v>
+                </c:pt>
+                <c:pt idx="11">
+                  <c:v>42735.0</c:v>
+                </c:pt>
+                <c:pt idx="12">
+                  <c:v>42766.0</c:v>
+                </c:pt>
+                <c:pt idx="13">
+                  <c:v>42794.0</c:v>
+                </c:pt>
+                <c:pt idx="14">
+                  <c:v>42825.0</c:v>
+                </c:pt>
+                <c:pt idx="15">
+                  <c:v>42855.0</c:v>
+                </c:pt>
+                <c:pt idx="16">
+                  <c:v>42886.0</c:v>
+                </c:pt>
+                <c:pt idx="17">
+                  <c:v>42916.0</c:v>
+                </c:pt>
+                <c:pt idx="18">
+                  <c:v>42947.0</c:v>
+                </c:pt>
+                <c:pt idx="19">
+                  <c:v>42978.0</c:v>
+                </c:pt>
+                <c:pt idx="20">
+                  <c:v>43008.0</c:v>
+                </c:pt>
+                <c:pt idx="21">
+                  <c:v>43039.0</c:v>
+                </c:pt>
+                <c:pt idx="22">
+                  <c:v>43069.0</c:v>
+                </c:pt>
+                <c:pt idx="23">
+                  <c:v>43100.0</c:v>
+                </c:pt>
+                <c:pt idx="24">
+                  <c:v>43131.0</c:v>
+                </c:pt>
+                <c:pt idx="25">
+                  <c:v>43159.0</c:v>
+                </c:pt>
+                <c:pt idx="26">
+                  <c:v>43190.0</c:v>
+                </c:pt>
+                <c:pt idx="27">
+                  <c:v>43220.0</c:v>
+                </c:pt>
+                <c:pt idx="28">
+                  <c:v>43251.0</c:v>
+                </c:pt>
+                <c:pt idx="29">
+                  <c:v>43281.0</c:v>
+                </c:pt>
+                <c:pt idx="30">
+                  <c:v>43312.0</c:v>
+                </c:pt>
+                <c:pt idx="31">
+                  <c:v>43343.0</c:v>
+                </c:pt>
+                <c:pt idx="32">
+                  <c:v>43373.0</c:v>
+                </c:pt>
+                <c:pt idx="33">
+                  <c:v>43404.0</c:v>
+                </c:pt>
+                <c:pt idx="34">
+                  <c:v>43434.0</c:v>
+                </c:pt>
+                <c:pt idx="35">
+                  <c:v>43465.0</c:v>
+                </c:pt>
+                <c:pt idx="36">
+                  <c:v>43496.0</c:v>
+                </c:pt>
+                <c:pt idx="37">
+                  <c:v>43524.0</c:v>
+                </c:pt>
+                <c:pt idx="38">
+                  <c:v>43555.0</c:v>
+                </c:pt>
+                <c:pt idx="39">
+                  <c:v>43585.0</c:v>
+                </c:pt>
+                <c:pt idx="40">
+                  <c:v>43616.0</c:v>
+                </c:pt>
+                <c:pt idx="41">
+                  <c:v>43646.0</c:v>
+                </c:pt>
+                <c:pt idx="42">
+                  <c:v>43677.0</c:v>
+                </c:pt>
+                <c:pt idx="43">
+                  <c:v>43708.0</c:v>
+                </c:pt>
+                <c:pt idx="44">
+                  <c:v>43738.0</c:v>
+                </c:pt>
+                <c:pt idx="45">
+                  <c:v>43769.0</c:v>
+                </c:pt>
+                <c:pt idx="46">
+                  <c:v>43799.0</c:v>
+                </c:pt>
+                <c:pt idx="47">
+                  <c:v>43830.0</c:v>
+                </c:pt>
+                <c:pt idx="48">
+                  <c:v>43861.0</c:v>
+                </c:pt>
+                <c:pt idx="49">
+                  <c:v>43890.0</c:v>
+                </c:pt>
+                <c:pt idx="50">
+                  <c:v>43921.0</c:v>
+                </c:pt>
+                <c:pt idx="51">
+                  <c:v>43951.0</c:v>
+                </c:pt>
+                <c:pt idx="52">
+                  <c:v>43982.0</c:v>
+                </c:pt>
+                <c:pt idx="53">
+                  <c:v>44012.0</c:v>
+                </c:pt>
+                <c:pt idx="54">
+                  <c:v>44043.0</c:v>
+                </c:pt>
+                <c:pt idx="55">
+                  <c:v>44074.0</c:v>
+                </c:pt>
+                <c:pt idx="56">
+                  <c:v>44104.0</c:v>
+                </c:pt>
+                <c:pt idx="57">
+                  <c:v>44135.0</c:v>
+                </c:pt>
+                <c:pt idx="58">
+                  <c:v>44165.0</c:v>
+                </c:pt>
+                <c:pt idx="59">
+                  <c:v>44196.0</c:v>
+                </c:pt>
+                <c:pt idx="60">
+                  <c:v>44227.0</c:v>
+                </c:pt>
+                <c:pt idx="61">
+                  <c:v>44255.0</c:v>
+                </c:pt>
+                <c:pt idx="62">
+                  <c:v>44286.0</c:v>
+                </c:pt>
+                <c:pt idx="63">
+                  <c:v>44316.0</c:v>
+                </c:pt>
+                <c:pt idx="64">
+                  <c:v>44347.0</c:v>
+                </c:pt>
+                <c:pt idx="65">
+                  <c:v>44377.0</c:v>
+                </c:pt>
+                <c:pt idx="66">
+                  <c:v>44408.0</c:v>
+                </c:pt>
+                <c:pt idx="67">
+                  <c:v>44439.0</c:v>
+                </c:pt>
+                <c:pt idx="68">
+                  <c:v>44469.0</c:v>
+                </c:pt>
+                <c:pt idx="69">
+                  <c:v>44500.0</c:v>
+                </c:pt>
+                <c:pt idx="70">
+                  <c:v>44530.0</c:v>
+                </c:pt>
+                <c:pt idx="71">
+                  <c:v>44561.0</c:v>
+                </c:pt>
+                <c:pt idx="72">
+                  <c:v>44592.0</c:v>
+                </c:pt>
+                <c:pt idx="73">
+                  <c:v>44620.0</c:v>
+                </c:pt>
+                <c:pt idx="74">
+                  <c:v>44651.0</c:v>
+                </c:pt>
+                <c:pt idx="75">
+                  <c:v>44681.0</c:v>
+                </c:pt>
+                <c:pt idx="76">
+                  <c:v>44712.0</c:v>
+                </c:pt>
+                <c:pt idx="77">
+                  <c:v>44742.0</c:v>
+                </c:pt>
+                <c:pt idx="78">
+                  <c:v>44773.0</c:v>
+                </c:pt>
+                <c:pt idx="79">
+                  <c:v>44804.0</c:v>
+                </c:pt>
+                <c:pt idx="80">
+                  <c:v>44834.0</c:v>
+                </c:pt>
+                <c:pt idx="81">
+                  <c:v>44865.0</c:v>
+                </c:pt>
+                <c:pt idx="82">
+                  <c:v>44895.0</c:v>
+                </c:pt>
+                <c:pt idx="83">
+                  <c:v>44926.0</c:v>
+                </c:pt>
+                <c:pt idx="84">
+                  <c:v>44957.0</c:v>
+                </c:pt>
+                <c:pt idx="85">
+                  <c:v>44985.0</c:v>
+                </c:pt>
+                <c:pt idx="86">
+                  <c:v>45016.0</c:v>
+                </c:pt>
+                <c:pt idx="87">
+                  <c:v>45046.0</c:v>
+                </c:pt>
+                <c:pt idx="88">
+                  <c:v>45077.0</c:v>
+                </c:pt>
+                <c:pt idx="89">
+                  <c:v>45107.0</c:v>
+                </c:pt>
+                <c:pt idx="90">
+                  <c:v>45138.0</c:v>
+                </c:pt>
+                <c:pt idx="91">
+                  <c:v>45169.0</c:v>
+                </c:pt>
+                <c:pt idx="92">
+                  <c:v>45199.0</c:v>
+                </c:pt>
+                <c:pt idx="93">
+                  <c:v>45230.0</c:v>
+                </c:pt>
+                <c:pt idx="94">
+                  <c:v>45260.0</c:v>
+                </c:pt>
+                <c:pt idx="95">
+                  <c:v>45291.0</c:v>
+                </c:pt>
+                <c:pt idx="96">
+                  <c:v>45322.0</c:v>
+                </c:pt>
+                <c:pt idx="97">
+                  <c:v>45351.0</c:v>
+                </c:pt>
+                <c:pt idx="98">
+                  <c:v>45382.0</c:v>
+                </c:pt>
+                <c:pt idx="99">
+                  <c:v>45412.0</c:v>
+                </c:pt>
+                <c:pt idx="100">
+                  <c:v>45443.0</c:v>
+                </c:pt>
+                <c:pt idx="101">
+                  <c:v>45473.0</c:v>
+                </c:pt>
+                <c:pt idx="102">
+                  <c:v>45504.0</c:v>
+                </c:pt>
+                <c:pt idx="103">
+                  <c:v>45535.0</c:v>
+                </c:pt>
+                <c:pt idx="104">
+                  <c:v>45565.0</c:v>
+                </c:pt>
+                <c:pt idx="105">
+                  <c:v>45596.0</c:v>
+                </c:pt>
+                <c:pt idx="106">
+                  <c:v>45626.0</c:v>
+                </c:pt>
+                <c:pt idx="107">
+                  <c:v>45657.0</c:v>
+                </c:pt>
+                <c:pt idx="108">
+                  <c:v>45688.0</c:v>
+                </c:pt>
+                <c:pt idx="109">
+                  <c:v>45716.0</c:v>
+                </c:pt>
+                <c:pt idx="110">
+                  <c:v>45747.0</c:v>
+                </c:pt>
+                <c:pt idx="111">
+                  <c:v>45777.0</c:v>
+                </c:pt>
+                <c:pt idx="112">
+                  <c:v>45808.0</c:v>
+                </c:pt>
+                <c:pt idx="113">
+                  <c:v>45838.0</c:v>
+                </c:pt>
+                <c:pt idx="114">
+                  <c:v>45869.0</c:v>
+                </c:pt>
+                <c:pt idx="115">
+                  <c:v>45900.0</c:v>
+                </c:pt>
+                <c:pt idx="116">
+                  <c:v>45930.0</c:v>
+                </c:pt>
+                <c:pt idx="117">
+                  <c:v>45961.0</c:v>
+                </c:pt>
+                <c:pt idx="118">
+                  <c:v>45991.0</c:v>
+                </c:pt>
+                <c:pt idx="119">
+                  <c:v>46022.0</c:v>
+                </c:pt>
+                <c:pt idx="120">
+                  <c:v>46053.0</c:v>
+                </c:pt>
+                <c:pt idx="121">
+                  <c:v>46081.0</c:v>
+                </c:pt>
+                <c:pt idx="122">
+                  <c:v>46112.0</c:v>
+                </c:pt>
+                <c:pt idx="123">
+                  <c:v>46142.0</c:v>
+                </c:pt>
+                <c:pt idx="124">
+                  <c:v>46173.0</c:v>
+                </c:pt>
+                <c:pt idx="125">
+                  <c:v>46203.0</c:v>
+                </c:pt>
+                <c:pt idx="126">
+                  <c:v>46234.0</c:v>
+                </c:pt>
+                <c:pt idx="127">
+                  <c:v>46265.0</c:v>
+                </c:pt>
+                <c:pt idx="128">
+                  <c:v>46295.0</c:v>
+                </c:pt>
+              </c:numCache>
+            </c:numRef>
+          </c:cat>
+          <c:val>
+            <c:numRef>
+              <c:f>Sheet1!$D$2:$D$130</c:f>
+              <c:numCache>
+                <c:formatCode>General</c:formatCode>
+                <c:ptCount val="129"/>
+                <c:pt idx="0">
+                  <c:v>99591.01518538264</c:v>
+                </c:pt>
+                <c:pt idx="1">
+                  <c:v>99438.04905830644</c:v>
+                </c:pt>
+                <c:pt idx="2">
+                  <c:v>100107.1583412142</c:v>
+                </c:pt>
+                <c:pt idx="3">
+                  <c:v>99435.5724031931</c:v>
+                </c:pt>
+                <c:pt idx="4">
+                  <c:v>100130.97659093322</c:v>
+                </c:pt>
+                <c:pt idx="5">
+                  <c:v>99601.41477196787</c:v>
+                </c:pt>
+                <c:pt idx="6">
+                  <c:v>98752.55480346642</c:v>
+                </c:pt>
+                <c:pt idx="7">
+                  <c:v>97638.87878229556</c:v>
+                </c:pt>
+                <c:pt idx="8">
+                  <c:v>99805.77194421735</c:v>
+                </c:pt>
+                <c:pt idx="9">
+                  <c:v>98722.5235813678</c:v>
+                </c:pt>
+                <c:pt idx="10">
+                  <c:v>99224.45079292927</c:v>
+                </c:pt>
+                <c:pt idx="11">
+                  <c:v>99021.54113309812</c:v>
+                </c:pt>
+                <c:pt idx="12">
+                  <c:v>98097.67461839222</c:v>
+                </c:pt>
+                <c:pt idx="13">
+                  <c:v>97960.42146187388</c:v>
+                </c:pt>
+                <c:pt idx="14">
+                  <c:v>98574.6927848104</c:v>
+                </c:pt>
+                <c:pt idx="15">
+                  <c:v>97509.29590382912</c:v>
+                </c:pt>
+                <c:pt idx="16">
+                  <c:v>97410.9737649614</c:v>
+                </c:pt>
+                <c:pt idx="17">
+                  <c:v>98222.17371245062</c:v>
+                </c:pt>
+                <c:pt idx="18">
+                  <c:v>97621.20157593026</c:v>
+                </c:pt>
+                <c:pt idx="19">
+                  <c:v>98858.2466368879</c:v>
+                </c:pt>
+                <c:pt idx="20">
+                  <c:v>98203.59515387754</c:v>
+                </c:pt>
+                <c:pt idx="21">
+                  <c:v>98757.49126217527</c:v>
+                </c:pt>
+                <c:pt idx="22">
+                  <c:v>98564.37788843217</c:v>
+                </c:pt>
+                <c:pt idx="23">
+                  <c:v>96881.9573241866</c:v>
+                </c:pt>
+                <c:pt idx="24">
+                  <c:v>97746.04480697987</c:v>
+                </c:pt>
+                <c:pt idx="25">
+                  <c:v>100614.56658355112</c:v>
+                </c:pt>
+                <c:pt idx="26">
+                  <c:v>105216.24745763604</c:v>
+                </c:pt>
+                <c:pt idx="27">
+                  <c:v>107559.85052552828</c:v>
+                </c:pt>
+                <c:pt idx="28">
+                  <c:v>106506.71221927454</c:v>
+                </c:pt>
+                <c:pt idx="29">
+                  <c:v>106266.64791155118</c:v>
+                </c:pt>
+                <c:pt idx="30">
+                  <c:v>108405.66658972326</c:v>
+                </c:pt>
+                <c:pt idx="31">
+                  <c:v>107856.6349373659</c:v>
+                </c:pt>
+                <c:pt idx="32">
+                  <c:v>107158.22201673068</c:v>
+                </c:pt>
+                <c:pt idx="33">
+                  <c:v>111755.54725288834</c:v>
+                </c:pt>
+                <c:pt idx="34">
+                  <c:v>114500.46393390364</c:v>
+                </c:pt>
+                <c:pt idx="35">
+                  <c:v>119058.242111317</c:v>
+                </c:pt>
+                <c:pt idx="36">
+                  <c:v>118309.52863977048</c:v>
+                </c:pt>
+                <c:pt idx="37">
+                  <c:v>117424.60805196666</c:v>
+                </c:pt>
+                <c:pt idx="38">
+                  <c:v>117606.20257366826</c:v>
+                </c:pt>
+                <c:pt idx="39">
+                  <c:v>117059.02370328768</c:v>
+                </c:pt>
+                <c:pt idx="40">
+                  <c:v>115002.44067778364</c:v>
+                </c:pt>
+                <c:pt idx="41">
+                  <c:v>116776.93390295633</c:v>
+                </c:pt>
+                <c:pt idx="42">
+                  <c:v>115795.02055705852</c:v>
+                </c:pt>
+                <c:pt idx="43">
+                  <c:v>117362.26951958728</c:v>
+                </c:pt>
+                <c:pt idx="44">
+                  <c:v>117118.9138225738</c:v>
+                </c:pt>
+                <c:pt idx="45">
+                  <c:v>117022.7901372358</c:v>
+                </c:pt>
+                <c:pt idx="46">
+                  <c:v>115940.87382720472</c:v>
+                </c:pt>
+                <c:pt idx="47">
+                  <c:v>115869.70684608306</c:v>
+                </c:pt>
+                <c:pt idx="48">
+                  <c:v>117811.95547931164</c:v>
+                </c:pt>
+                <c:pt idx="49">
+                  <c:v>119543.2059983116</c:v>
+                </c:pt>
+                <c:pt idx="50">
+                  <c:v>118071.90649733887</c:v>
+                </c:pt>
+                <c:pt idx="51">
+                  <c:v>117673.65223630004</c:v>
+                </c:pt>
+                <c:pt idx="52">
+                  <c:v>115124.32274933271</c:v>
+                </c:pt>
+                <c:pt idx="53">
+                  <c:v>119004.5393513123</c:v>
+                </c:pt>
+                <c:pt idx="54">
+                  <c:v>119344.233028736</c:v>
+                </c:pt>
+                <c:pt idx="55">
+                  <c:v>119794.83343054044</c:v>
+                </c:pt>
+                <c:pt idx="56">
+                  <c:v>121463.58253898812</c:v>
+                </c:pt>
+                <c:pt idx="57">
+                  <c:v>122775.18547749032</c:v>
+                </c:pt>
+                <c:pt idx="58">
+                  <c:v>121604.01717662468</c:v>
+                </c:pt>
+                <c:pt idx="59">
+                  <c:v>120712.18922388228</c:v>
+                </c:pt>
+                <c:pt idx="60">
+                  <c:v>122732.14745734892</c:v>
+                </c:pt>
+                <c:pt idx="61">
+                  <c:v>122036.96389881542</c:v>
+                </c:pt>
+                <c:pt idx="62">
+                  <c:v>124278.73262412442</c:v>
+                </c:pt>
+                <c:pt idx="63">
+                  <c:v>125680.60655735602</c:v>
+                </c:pt>
+                <c:pt idx="64">
+                  <c:v>127628.73930656418</c:v>
+                </c:pt>
+                <c:pt idx="65">
+                  <c:v>128463.07737774416</c:v>
+                </c:pt>
+                <c:pt idx="66">
+                  <c:v>129299.82166265923</c:v>
+                </c:pt>
+                <c:pt idx="67">
+                  <c:v>129015.58143492586</c:v>
+                </c:pt>
+                <c:pt idx="68">
+                  <c:v>129296.29215370968</c:v>
+                </c:pt>
+                <c:pt idx="69">
+                  <c:v>130062.21319680456</c:v>
+                </c:pt>
+                <c:pt idx="70">
+                  <c:v>129045.0262057246</c:v>
+                </c:pt>
+                <c:pt idx="71">
+                  <c:v>130012.64700188806</c:v>
+                </c:pt>
+                <c:pt idx="72">
+                  <c:v>129181.05753737422</c:v>
+                </c:pt>
+                <c:pt idx="73">
+                  <c:v>133192.0927027133</c:v>
+                </c:pt>
+                <c:pt idx="74">
+                  <c:v>133016.24821829662</c:v>
+                </c:pt>
+                <c:pt idx="75">
+                  <c:v>141425.55642953052</c:v>
+                </c:pt>
+                <c:pt idx="76">
+                  <c:v>145373.24440942425</c:v>
+                </c:pt>
+                <c:pt idx="77">
+                  <c:v>145510.0906801665</c:v>
+                </c:pt>
+                <c:pt idx="78">
+                  <c:v>144951.87807750006</c:v>
+                </c:pt>
+                <c:pt idx="79">
+                  <c:v>149009.9380311114</c:v>
+                </c:pt>
+                <c:pt idx="80">
+                  <c:v>147727.3019284137</c:v>
+                </c:pt>
+                <c:pt idx="81">
+                  <c:v>154287.3041510887</c:v>
+                </c:pt>
+                <c:pt idx="82">
+                  <c:v>155825.01453512043</c:v>
+                </c:pt>
+                <c:pt idx="83">
+                  <c:v>157349.54565493128</c:v>
+                </c:pt>
+                <c:pt idx="84">
+                  <c:v>159090.18880300105</c:v>
+                </c:pt>
+                <c:pt idx="85">
+                  <c:v>158611.49219258715</c:v>
+                </c:pt>
+                <c:pt idx="86">
+                  <c:v>159768.50365115647</c:v>
+                </c:pt>
+                <c:pt idx="87">
+                  <c:v>162363.8630402268</c:v>
+                </c:pt>
+                <c:pt idx="88">
+                  <c:v>164908.99901905545</c:v>
+                </c:pt>
+                <c:pt idx="89">
+                  <c:v>167171.84555968153</c:v>
+                </c:pt>
+                <c:pt idx="90">
+                  <c:v>167340.98301748256</c:v>
+                </c:pt>
+                <c:pt idx="91">
+                  <c:v>172247.01828855943</c:v>
+                </c:pt>
+                <c:pt idx="92">
+                  <c:v>171777.8234544879</c:v>
+                </c:pt>
+                <c:pt idx="93">
+                  <c:v>170390.18928614605</c:v>
+                </c:pt>
+                <c:pt idx="94">
+                  <c:v>172143.11288568098</c:v>
+                </c:pt>
+                <c:pt idx="95">
+                  <c:v>171354.1509113366</c:v>
+                </c:pt>
+                <c:pt idx="96">
+                  <c:v>173159.54123928896</c:v>
+                </c:pt>
+                <c:pt idx="97">
+                  <c:v>172506.3680790211</c:v>
+                </c:pt>
+                <c:pt idx="98">
+                  <c:v>172043.3395882517</c:v>
+                </c:pt>
+                <c:pt idx="99">
+                  <c:v>175603.946078825</c:v>
+                </c:pt>
+                <c:pt idx="100">
+                  <c:v>174815.7608255943</c:v>
+                </c:pt>
+                <c:pt idx="101">
+                  <c:v>174170.23505241988</c:v>
+                </c:pt>
+                <c:pt idx="102">
+                  <c:v>177731.22894291865</c:v>
+                </c:pt>
+                <c:pt idx="103">
+                  <c:v>175777.4670093525</c:v>
+                </c:pt>
+                <c:pt idx="104">
+                  <c:v>179270.7270846629</c:v>
+                </c:pt>
+                <c:pt idx="105">
+                  <c:v>181482.8466571729</c:v>
+                </c:pt>
+                <c:pt idx="106">
+                  <c:v>180288.9499200997</c:v>
+                </c:pt>
+                <c:pt idx="107">
+                  <c:v>183545.10943689247</c:v>
+                </c:pt>
+                <c:pt idx="108">
+                  <c:v>182901.90651532213</c:v>
+                </c:pt>
+                <c:pt idx="109">
+                  <c:v>185954.1453602558</c:v>
+                </c:pt>
+                <c:pt idx="110">
+                  <c:v>184470.1058038284</c:v>
+                </c:pt>
+                <c:pt idx="111">
+                  <c:v>195507.69342291047</c:v>
+                </c:pt>
+                <c:pt idx="112">
+                  <c:v>193664.6535567051</c:v>
+                </c:pt>
+                <c:pt idx="113">
+                  <c:v>191989.49915856257</c:v>
+                </c:pt>
+                <c:pt idx="114">
+                  <c:v>189691.7253791777</c:v>
+                </c:pt>
+                <c:pt idx="115">
+                  <c:v>189355.45293042136</c:v>
+                </c:pt>
+                <c:pt idx="116">
+                  <c:v>186439.29028171196</c:v>
+                </c:pt>
+                <c:pt idx="117">
+                  <c:v>188425.53288507185</c:v>
+                </c:pt>
+                <c:pt idx="118">
+                  <c:v>189466.1267133275</c:v>
+                </c:pt>
+                <c:pt idx="119">
+                  <c:v>188779.5308247612</c:v>
+                </c:pt>
+                <c:pt idx="120">
+                  <c:v>184547.72824022005</c:v>
+                </c:pt>
+                <c:pt idx="121">
+                  <c:v>184918.7506485177</c:v>
+                </c:pt>
+                <c:pt idx="122">
+                  <c:v>186974.76459965605</c:v>
+                </c:pt>
+                <c:pt idx="123">
+                  <c:v>185381.93540374213</c:v>
+                </c:pt>
+                <c:pt idx="124">
+                  <c:v>183994.95955711804</c:v>
+                </c:pt>
+                <c:pt idx="125">
+                  <c:v>187081.2387327178</c:v>
+                </c:pt>
+                <c:pt idx="126">
+                  <c:v>183453.60432708648</c:v>
+                </c:pt>
+                <c:pt idx="127">
+                  <c:v>185131.1900861156</c:v>
+                </c:pt>
+                <c:pt idx="128">
+                  <c:v>184139.89585857745</c:v>
+                </c:pt>
+              </c:numCache>
+            </c:numRef>
+          </c:val>
+          <c:smooth val="0"/>
+        </c:ser>
+        <c:marker val="1"/>
+        <c:smooth val="0"/>
+        <c:axId val="2118791784"/>
+        <c:axId val="2140495176"/>
+      </c:lineChart>
+      <c:dateAx>
+        <c:axId val="2118791784"/>
         <c:scaling>
           <c:orientation val="minMax"/>
         </c:scaling>
         <c:delete val="0"/>
         <c:axPos val="b"/>
+        <c:numFmt formatCode="mmm-yy" sourceLinked="0"/>
         <c:majorTickMark val="out"/>
         <c:minorTickMark val="none"/>
-        <c:tickLblPos val="low"/>
+        <c:tickLblPos val="nextTo"/>
         <c:spPr>
           <a:ln>
             <a:solidFill>
@@ -8414,16 +10715,17 @@
             </a:pPr>
           </a:p>
         </c:txPr>
-        <c:crossAx val="-2113994440"/>
+        <c:crossAx val="2140495176"/>
         <c:crosses val="autoZero"/>
         <c:auto val="1"/>
-        <c:lblAlgn val="ctr"/>
         <c:lblOffset val="100"/>
-        <c:noMultiLvlLbl val="0"/>
-      </c:catAx>
+        <c:baseTimeUnit val="days"/>
+      </c:dateAx>
       <c:valAx>
-        <c:axId val="-2113994440"/>
-        <c:scaling/>
+        <c:axId val="2140495176"/>
+        <c:scaling>
+          <c:min val="80000.0"/>
+        </c:scaling>
         <c:delete val="0"/>
         <c:axPos val="l"/>
         <c:majorGridlines>
@@ -8447,7 +10749,7 @@
                       <a:srgbClr val="6B7280"/>
                     </a:solidFill>
                   </a:rPr>
-                  <a:t>Sharpe by decision clock</a:t>
+                  <a:t>equity on $100,000 (1x, 1 bp/round trip)</a:t>
                 </a:r>
               </a:p>
             </c:rich>
@@ -8455,7 +10757,7 @@
           <c:layout/>
           <c:overlay val="0"/>
         </c:title>
-        <c:numFmt formatCode="0.00" sourceLinked="0"/>
+        <c:numFmt formatCode="#,##0" sourceLinked="0"/>
         <c:majorTickMark val="out"/>
         <c:minorTickMark val="none"/>
         <c:tickLblPos val="nextTo"/>
@@ -8479,12 +10781,13 @@
             </a:pPr>
           </a:p>
         </c:txPr>
-        <c:crossAx val="-2068027336"/>
+        <c:crossAx val="2118791784"/>
         <c:crosses val="autoZero"/>
       </c:valAx>
     </c:plotArea>
     <c:legend>
       <c:legendPos val="b"/>
+      <c:layout/>
       <c:overlay val="0"/>
       <c:txPr>
         <a:bodyPr/>
@@ -8496,7 +10799,9 @@
         </a:p>
       </c:txPr>
     </c:legend>
+    <c:plotVisOnly val="1"/>
     <c:dispBlanksAs val="gap"/>
+    <c:showDLblsOverMax val="0"/>
   </c:chart>
   <c:txPr>
     <a:bodyPr/>
@@ -17806,8 +20111,8 @@
           <p:nvPr/>
         </p:nvGraphicFramePr>
         <p:xfrm>
-          <a:off x="548640" y="3200400"/>
-          <a:ext cx="6766560" cy="2834640"/>
+          <a:off x="548640" y="3154680"/>
+          <a:ext cx="6766560" cy="2926080"/>
         </p:xfrm>
         <a:graphic>
           <a:graphicData uri="http://schemas.openxmlformats.org/drawingml/2006/chart">
@@ -17940,7 +20245,7 @@
                 </a:solidFill>
                 <a:latin typeface="Calibri"/>
               </a:rPr>
-              <a:t>Sharpe 1.22 with t = 4.0, in both halves of the decade, drawdown 8%. SPY 0.63. IWM loses.</a:t>
+              <a:t>Sharpe 1.22 with t = 4.0, in both halves of the decade, drawdown 8%. SPY 0.63. IWM loses. In dollars: $100,000 in the bot's 50/50 book becomes $184,140 (+84,140) over the decade at 1×, worst drawdown 7%, losing years 2016, 2017, 2019, 2026.</a:t>
             </a:r>
           </a:p>
           <a:p>

</xml_diff>